<commit_message>
docs: reescreve o resumo do pôster para não repetir o resumo aprovado
Co-Authored-By: Claude Opus 5.5 <noreply@anthropic.com>
Claude-Session: https://claude.ai/code/session_0155ZQW51WJr492adJxnaXxR
</commit_message>
<xml_diff>
--- a/docs/poster-wtdcc-2026/poster_wtdcc_2026_luna.pptx
+++ b/docs/poster-wtdcc-2026/poster_wtdcc_2026_luna.pptx
@@ -476,7 +476,7 @@
         <p:spPr>
           <a:xfrm>
             <a:off x="1080366" y="6319189"/>
-            <a:ext cx="13495549" cy="19440000"/>
+            <a:ext cx="13495549" cy="19980000"/>
           </a:xfrm>
           <a:custGeom>
             <a:avLst/>
@@ -550,7 +550,7 @@
                 <a:latin typeface="Arial"/>
                 <a:cs typeface="Arial"/>
               </a:rPr>
-              <a:t>Aplicativos de ciclo menstrual guardam dados sensíveis, mas costumam apenas declarar que os protegem. Este trabalho propõe quatro verificações reprodutíveis e as aplica ao Luna, aplicativo Android de código aberto com backend auto-hospedável. Os testes confirmaram controle de acesso, isolamento entre contas, nenhuma credencial exposta e nenhum rastreador de terceiros.</a:t>
+              <a:t>Em vez de confiar na política de privacidade, este trabalho testa a proteção de dados no próprio código do Luna, aplicativo Android de ciclo menstrual com backend auto-hospedável. Quatro verificações reprodutíveis confirmaram controle de acesso, isolamento entre contas e ausência de credenciais expostas e de rastreadores, e também apontaram o que ainda falta proteger.</a:t>
             </a:r>
           </a:p>
           <a:p>

</xml_diff>

<commit_message>
docs: preenche o espaço em branco da coluna esquerda do pôster
Distribui o espaço entre os parágrafos e alinha o fim da Figura 1 ao
fim da coluna direita.

Co-Authored-By: Claude Opus 5.5 <noreply@anthropic.com>
Claude-Session: https://claude.ai/code/session_0155ZQW51WJr492adJxnaXxR
</commit_message>
<xml_diff>
--- a/docs/poster-wtdcc-2026/poster_wtdcc_2026_luna.pptx
+++ b/docs/poster-wtdcc-2026/poster_wtdcc_2026_luna.pptx
@@ -476,7 +476,7 @@
         <p:spPr>
           <a:xfrm>
             <a:off x="1080366" y="6319189"/>
-            <a:ext cx="13495549" cy="19980000"/>
+            <a:ext cx="13495549" cy="22541962"/>
           </a:xfrm>
           <a:custGeom>
             <a:avLst/>
@@ -513,11 +513,14 @@
           <a:lstStyle/>
           <a:p>
             <a:pPr algn="just">
-              <a:spcBef>
-                <a:spcPts val="0"/>
-              </a:spcBef>
-              <a:spcAft>
-                <a:spcPts val="600"/>
+              <a:lnSpc>
+                <a:spcPct val="107000"/>
+              </a:lnSpc>
+              <a:spcBef>
+                <a:spcPts val="0"/>
+              </a:spcBef>
+              <a:spcAft>
+                <a:spcPts val="1000"/>
               </a:spcAft>
               <a:buNone/>
             </a:pPr>
@@ -534,11 +537,14 @@
           </a:p>
           <a:p>
             <a:pPr algn="just" indent="685800">
-              <a:spcBef>
-                <a:spcPts val="0"/>
-              </a:spcBef>
-              <a:spcAft>
-                <a:spcPts val="500"/>
+              <a:lnSpc>
+                <a:spcPct val="107000"/>
+              </a:lnSpc>
+              <a:spcBef>
+                <a:spcPts val="0"/>
+              </a:spcBef>
+              <a:spcAft>
+                <a:spcPts val="1800"/>
               </a:spcAft>
               <a:buNone/>
             </a:pPr>
@@ -555,11 +561,14 @@
           </a:p>
           <a:p>
             <a:pPr algn="just">
-              <a:spcBef>
-                <a:spcPts val="1100"/>
-              </a:spcBef>
-              <a:spcAft>
-                <a:spcPts val="600"/>
+              <a:lnSpc>
+                <a:spcPct val="107000"/>
+              </a:lnSpc>
+              <a:spcBef>
+                <a:spcPts val="2500"/>
+              </a:spcBef>
+              <a:spcAft>
+                <a:spcPts val="1000"/>
               </a:spcAft>
               <a:buNone/>
             </a:pPr>
@@ -576,11 +585,14 @@
           </a:p>
           <a:p>
             <a:pPr algn="just" indent="685800">
-              <a:spcBef>
-                <a:spcPts val="0"/>
-              </a:spcBef>
-              <a:spcAft>
-                <a:spcPts val="500"/>
+              <a:lnSpc>
+                <a:spcPct val="107000"/>
+              </a:lnSpc>
+              <a:spcBef>
+                <a:spcPts val="0"/>
+              </a:spcBef>
+              <a:spcAft>
+                <a:spcPts val="1800"/>
               </a:spcAft>
               <a:buNone/>
             </a:pPr>
@@ -597,11 +609,14 @@
           </a:p>
           <a:p>
             <a:pPr algn="just" indent="685800">
-              <a:spcBef>
-                <a:spcPts val="0"/>
-              </a:spcBef>
-              <a:spcAft>
-                <a:spcPts val="500"/>
+              <a:lnSpc>
+                <a:spcPct val="107000"/>
+              </a:lnSpc>
+              <a:spcBef>
+                <a:spcPts val="0"/>
+              </a:spcBef>
+              <a:spcAft>
+                <a:spcPts val="1800"/>
               </a:spcAft>
               <a:buNone/>
             </a:pPr>
@@ -618,11 +633,14 @@
           </a:p>
           <a:p>
             <a:pPr algn="just" indent="685800">
-              <a:spcBef>
-                <a:spcPts val="0"/>
-              </a:spcBef>
-              <a:spcAft>
-                <a:spcPts val="500"/>
+              <a:lnSpc>
+                <a:spcPct val="107000"/>
+              </a:lnSpc>
+              <a:spcBef>
+                <a:spcPts val="0"/>
+              </a:spcBef>
+              <a:spcAft>
+                <a:spcPts val="1800"/>
               </a:spcAft>
               <a:buNone/>
             </a:pPr>
@@ -649,11 +667,14 @@
           </a:p>
           <a:p>
             <a:pPr algn="just" indent="685800">
-              <a:spcBef>
-                <a:spcPts val="0"/>
-              </a:spcBef>
-              <a:spcAft>
-                <a:spcPts val="500"/>
+              <a:lnSpc>
+                <a:spcPct val="107000"/>
+              </a:lnSpc>
+              <a:spcBef>
+                <a:spcPts val="0"/>
+              </a:spcBef>
+              <a:spcAft>
+                <a:spcPts val="1800"/>
               </a:spcAft>
               <a:buNone/>
             </a:pPr>
@@ -680,11 +701,14 @@
           </a:p>
           <a:p>
             <a:pPr algn="just">
-              <a:spcBef>
-                <a:spcPts val="1100"/>
-              </a:spcBef>
-              <a:spcAft>
-                <a:spcPts val="600"/>
+              <a:lnSpc>
+                <a:spcPct val="107000"/>
+              </a:lnSpc>
+              <a:spcBef>
+                <a:spcPts val="2500"/>
+              </a:spcBef>
+              <a:spcAft>
+                <a:spcPts val="1000"/>
               </a:spcAft>
               <a:buNone/>
             </a:pPr>
@@ -701,11 +725,14 @@
           </a:p>
           <a:p>
             <a:pPr algn="just" indent="685800">
-              <a:spcBef>
-                <a:spcPts val="0"/>
-              </a:spcBef>
-              <a:spcAft>
-                <a:spcPts val="500"/>
+              <a:lnSpc>
+                <a:spcPct val="107000"/>
+              </a:lnSpc>
+              <a:spcBef>
+                <a:spcPts val="0"/>
+              </a:spcBef>
+              <a:spcAft>
+                <a:spcPts val="1800"/>
               </a:spcAft>
               <a:buNone/>
             </a:pPr>
@@ -722,11 +749,14 @@
           </a:p>
           <a:p>
             <a:pPr algn="just" marL="571500" indent="-571500">
-              <a:spcBef>
-                <a:spcPts val="0"/>
-              </a:spcBef>
-              <a:spcAft>
-                <a:spcPts val="300"/>
+              <a:lnSpc>
+                <a:spcPct val="107000"/>
+              </a:lnSpc>
+              <a:spcBef>
+                <a:spcPts val="0"/>
+              </a:spcBef>
+              <a:spcAft>
+                <a:spcPts val="1100"/>
               </a:spcAft>
               <a:buFont typeface="+mj-lt"/>
               <a:buAutoNum type="arabicPeriod"/>
@@ -754,11 +784,14 @@
           </a:p>
           <a:p>
             <a:pPr algn="just" marL="571500" indent="-571500">
-              <a:spcBef>
-                <a:spcPts val="0"/>
-              </a:spcBef>
-              <a:spcAft>
-                <a:spcPts val="300"/>
+              <a:lnSpc>
+                <a:spcPct val="107000"/>
+              </a:lnSpc>
+              <a:spcBef>
+                <a:spcPts val="0"/>
+              </a:spcBef>
+              <a:spcAft>
+                <a:spcPts val="1100"/>
               </a:spcAft>
               <a:buFont typeface="+mj-lt"/>
               <a:buAutoNum type="arabicPeriod"/>
@@ -786,11 +819,14 @@
           </a:p>
           <a:p>
             <a:pPr algn="just" marL="571500" indent="-571500">
-              <a:spcBef>
-                <a:spcPts val="0"/>
-              </a:spcBef>
-              <a:spcAft>
-                <a:spcPts val="300"/>
+              <a:lnSpc>
+                <a:spcPct val="107000"/>
+              </a:lnSpc>
+              <a:spcBef>
+                <a:spcPts val="0"/>
+              </a:spcBef>
+              <a:spcAft>
+                <a:spcPts val="1100"/>
               </a:spcAft>
               <a:buFont typeface="+mj-lt"/>
               <a:buAutoNum type="arabicPeriod"/>
@@ -818,11 +854,14 @@
           </a:p>
           <a:p>
             <a:pPr algn="just" marL="571500" indent="-571500">
-              <a:spcBef>
-                <a:spcPts val="0"/>
-              </a:spcBef>
-              <a:spcAft>
-                <a:spcPts val="500"/>
+              <a:lnSpc>
+                <a:spcPct val="107000"/>
+              </a:lnSpc>
+              <a:spcBef>
+                <a:spcPts val="0"/>
+              </a:spcBef>
+              <a:spcAft>
+                <a:spcPts val="1800"/>
               </a:spcAft>
               <a:buFont typeface="+mj-lt"/>
               <a:buAutoNum type="arabicPeriod"/>
@@ -850,11 +889,14 @@
           </a:p>
           <a:p>
             <a:pPr algn="just" indent="685800">
-              <a:spcBef>
-                <a:spcPts val="0"/>
-              </a:spcBef>
-              <a:spcAft>
-                <a:spcPts val="500"/>
+              <a:lnSpc>
+                <a:spcPct val="107000"/>
+              </a:lnSpc>
+              <a:spcBef>
+                <a:spcPts val="0"/>
+              </a:spcBef>
+              <a:spcAft>
+                <a:spcPts val="1800"/>
               </a:spcAft>
               <a:buNone/>
             </a:pPr>
@@ -1346,8 +1388,8 @@
         </p:blipFill>
         <p:spPr>
           <a:xfrm>
-            <a:off x="1388849" y="27559189"/>
-            <a:ext cx="12878583" cy="8794402"/>
+            <a:off x="1230366" y="29149151"/>
+            <a:ext cx="13195549" cy="9010849"/>
           </a:xfrm>
           <a:prstGeom prst="rect">
             <a:avLst/>
@@ -1365,7 +1407,7 @@
         </p:nvSpPr>
         <p:spPr>
           <a:xfrm>
-            <a:off x="1080366" y="36533591"/>
+            <a:off x="1080366" y="38304000"/>
             <a:ext cx="13495549" cy="792000"/>
           </a:xfrm>
           <a:prstGeom prst="rect">

</xml_diff>